<commit_message>
docs: state the exact remaining gap in both PPTs — empty-board draw lacks only WhiteCanPreventBlackWin (black side proven by stealing)
</commit_message>
<xml_diff>
--- a/五子棋项目阶段汇报_穿插版.pptx
+++ b/五子棋项目阶段汇报_穿插版.pptx
@@ -1434,7 +1434,7 @@
           <a:lstStyle/>
           <a:p>
             <a:r>
-              <a:t>不足一：空棋盘开局求解和空棋盘和棋都未完成，目前只有中盘局面。</a:t>
+              <a:t>不足一：空棋盘开局求解未完成；空棋盘和棋其实只差一环——黑防白已用策略偷取证明，还缺白防黑，补上即可组合出空棋盘 StandardDraw。</a:t>
             </a:r>
           </a:p>
         </p:txBody>
@@ -22989,7 +22989,7 @@
                 <a:latin typeface="微软雅黑"/>
                 <a:ea typeface="微软雅黑"/>
               </a:rPr>
-              <a:t>空棋盘和棋 · 未完成</a:t>
+              <a:t>空棋盘和棋 · 只差“白防黑”一环</a:t>
             </a:r>
           </a:p>
         </p:txBody>
@@ -23029,7 +23029,7 @@
                 <a:latin typeface="微软雅黑"/>
                 <a:ea typeface="微软雅黑"/>
               </a:rPr>
-              <a:t>中盘 9 局面的和棋已验证；空棋盘 StandardDraw 仍是开放目标</a:t>
+              <a:t>黑防白 BlackCanPreventWhiteWin initialPosition 已证（策略偷取）；只差 WhiteCanPreventBlackWin initialPosition，即可组合出空棋盘 StandardDraw</a:t>
             </a:r>
           </a:p>
         </p:txBody>
@@ -24725,7 +24725,7 @@
                 <a:latin typeface="微软雅黑"/>
                 <a:ea typeface="微软雅黑"/>
               </a:rPr>
-              <a:t>未做：空棋盘开局求解 · 空棋盘和棋 · 大规模验证</a:t>
+              <a:t>未做：空棋盘开局求解 · 空棋盘“白防黑”（只差一环）· 大规模验证</a:t>
             </a:r>
           </a:p>
         </p:txBody>

</xml_diff>

<commit_message>
docs: simplify code pages in interleaved PPT — remove checker/native_decide internals, keep certificate structure and theorem combination
</commit_message>
<xml_diff>
--- a/五子棋项目阶段汇报_穿插版.pptx
+++ b/五子棋项目阶段汇报_穿插版.pptx
@@ -1084,7 +1084,7 @@
           <a:lstStyle/>
           <a:p>
             <a:r>
-              <a:t>实战第三页：最后三个局面。证书只是候选，Lean 检查通过才是定理。</a:t>
+              <a:t>实战第三页：最后三个局面，每局都有白防黑、黑防白两张防守证书。</a:t>
             </a:r>
           </a:p>
         </p:txBody>
@@ -1154,7 +1154,7 @@
           <a:lstStyle/>
           <a:p>
             <a:r>
-              <a:t>代码对照三：Draw7x7.lean 里两张证书的检查用 native_decide 机器重算，standardDraw_of_mutualDefense 把两张防守证书组合成 StandardDraw 定理——这就是“搜索器只出数据，定理由 Lean 内核保证”的直接体现。</a:t>
+              <a:t>代码对照三：Draw7x7.lean 里两张防守证书分别给出 WhiteCanPreventBlackWin 和 BlackCanPreventWhiteWin，standardDraw_of_mutualDefense 把它们组合成 StandardDraw 定理——和棋结论来自两张证书的组合。</a:t>
             </a:r>
           </a:p>
         </p:txBody>
@@ -10239,7 +10239,7 @@
                 <a:latin typeface="微软雅黑"/>
                 <a:ea typeface="微软雅黑"/>
               </a:rPr>
-              <a:t>代码对照 ②：证书数据结构与检查器</a:t>
+              <a:t>代码对照 ②：证书数据结构</a:t>
             </a:r>
           </a:p>
         </p:txBody>
@@ -10311,7 +10311,7 @@
                 <a:latin typeface="微软雅黑"/>
                 <a:ea typeface="微软雅黑"/>
               </a:rPr>
-              <a:t>可序列化的扁平证书节点 + 逐节点布尔检查器 —— 检查器不信任搜索器，对每个节点重新计算。</a:t>
+              <a:t>模式 B 的证书格式：可序列化的扁平节点数组，子树用下标引用。</a:t>
             </a:r>
           </a:p>
         </p:txBody>
@@ -10325,7 +10325,7 @@
         <p:spPr>
           <a:xfrm>
             <a:off x="566928" y="1554480"/>
-            <a:ext cx="11055096" cy="2834640"/>
+            <a:ext cx="11055096" cy="4206240"/>
           </a:xfrm>
           <a:prstGeom prst="roundRect">
             <a:avLst>
@@ -10429,7 +10429,7 @@
         <p:spPr>
           <a:xfrm>
             <a:off x="795528" y="2011680"/>
-            <a:ext cx="10597896" cy="2267711"/>
+            <a:ext cx="10597896" cy="3639311"/>
           </a:xfrm>
           <a:prstGeom prst="rect">
             <a:avLst/>
@@ -10443,7 +10443,7 @@
           <a:lstStyle/>
           <a:p>
             <a:r>
-              <a:rPr sz="1200" b="1">
+              <a:rPr sz="1300" b="1">
                 <a:solidFill>
                   <a:srgbClr val="7DC4FF"/>
                 </a:solidFill>
@@ -10455,7 +10455,7 @@
           </a:p>
           <a:p>
             <a:r>
-              <a:rPr sz="1200" b="0">
+              <a:rPr sz="1300" b="0">
                 <a:solidFill>
                   <a:srgbClr val="E8ECF4"/>
                 </a:solidFill>
@@ -10467,7 +10467,7 @@
           </a:p>
           <a:p>
             <a:r>
-              <a:rPr sz="1200" b="0">
+              <a:rPr sz="1300" b="0">
                 <a:solidFill>
                   <a:srgbClr val="E8ECF4"/>
                 </a:solidFill>
@@ -10479,7 +10479,7 @@
           </a:p>
           <a:p>
             <a:r>
-              <a:rPr sz="1200" b="0">
+              <a:rPr sz="1300" b="0">
                 <a:solidFill>
                   <a:srgbClr val="E8ECF4"/>
                 </a:solidFill>
@@ -10491,7 +10491,7 @@
           </a:p>
           <a:p>
             <a:r>
-              <a:rPr sz="1200" b="0">
+              <a:rPr sz="1300" b="0">
                 <a:solidFill>
                   <a:srgbClr val="E8ECF4"/>
                 </a:solidFill>
@@ -10503,7 +10503,7 @@
           </a:p>
           <a:p>
             <a:r>
-              <a:rPr sz="1200" b="1">
+              <a:rPr sz="1300" b="1">
                 <a:solidFill>
                   <a:srgbClr val="7DC4FF"/>
                 </a:solidFill>
@@ -10515,7 +10515,7 @@
           </a:p>
           <a:p>
             <a:r>
-              <a:rPr sz="1200" b="0">
+              <a:rPr sz="1300" b="0">
                 <a:solidFill>
                   <a:srgbClr val="E8ECF4"/>
                 </a:solidFill>
@@ -10527,7 +10527,7 @@
           </a:p>
           <a:p>
             <a:r>
-              <a:rPr sz="1200" b="0">
+              <a:rPr sz="1300" b="0">
                 <a:solidFill>
                   <a:srgbClr val="E8ECF4"/>
                 </a:solidFill>
@@ -10539,7 +10539,7 @@
           </a:p>
           <a:p>
             <a:r>
-              <a:rPr sz="1200" b="0">
+              <a:rPr sz="1300" b="0">
                 <a:solidFill>
                   <a:srgbClr val="E8ECF4"/>
                 </a:solidFill>
@@ -10547,6 +10547,42 @@
                 <a:ea typeface="微软雅黑"/>
               </a:rPr>
               <a:t>  nodes : Array DefenseCertificateNode</a:t>
+            </a:r>
+          </a:p>
+          <a:p>
+            <a:r>
+              <a:rPr sz="1300" b="0">
+                <a:solidFill>
+                  <a:srgbClr val="E8ECF4"/>
+                </a:solidFill>
+                <a:latin typeface="Consolas"/>
+                <a:ea typeface="微软雅黑"/>
+              </a:rPr>
+              <a:t/>
+            </a:r>
+          </a:p>
+          <a:p>
+            <a:r>
+              <a:rPr sz="1300" b="0" i="1">
+                <a:solidFill>
+                  <a:srgbClr val="8A99B4"/>
+                </a:solidFill>
+                <a:latin typeface="Consolas"/>
+                <a:ea typeface="微软雅黑"/>
+              </a:rPr>
+              <a:t>-- 三种节点：terminal 终局 / defenderMove 防守方一步 /</a:t>
+            </a:r>
+          </a:p>
+          <a:p>
+            <a:r>
+              <a:rPr sz="1300" b="0" i="1">
+                <a:solidFill>
+                  <a:srgbClr val="8A99B4"/>
+                </a:solidFill>
+                <a:latin typeface="Consolas"/>
+                <a:ea typeface="微软雅黑"/>
+              </a:rPr>
+              <a:t>-- attackerMoves 攻击方全部应手（children 数组）</a:t>
             </a:r>
           </a:p>
         </p:txBody>
@@ -10559,21 +10595,19 @@
         </p:nvSpPr>
         <p:spPr>
           <a:xfrm>
-            <a:off x="566928" y="4526280"/>
-            <a:ext cx="11055096" cy="1783080"/>
+            <a:off x="566928" y="5897880"/>
+            <a:ext cx="3593592" cy="457200"/>
           </a:xfrm>
           <a:prstGeom prst="roundRect">
             <a:avLst>
-              <a:gd name="adj" fmla="val 4000"/>
+              <a:gd name="adj" fmla="val 12000"/>
             </a:avLst>
           </a:prstGeom>
           <a:solidFill>
-            <a:srgbClr val="141A2B"/>
+            <a:srgbClr val="F1F3F7"/>
           </a:solidFill>
-          <a:ln w="12700">
-            <a:solidFill>
-              <a:srgbClr val="3B5998"/>
-            </a:solidFill>
+          <a:ln>
+            <a:noFill/>
           </a:ln>
           <a:effectLst/>
         </p:spPr>
@@ -10601,22 +10635,94 @@
       </p:sp>
       <p:sp>
         <p:nvSpPr>
-          <p:cNvPr id="11" name="Rounded Rectangle 10"/>
+          <p:cNvPr id="11" name="TextBox 10"/>
+          <p:cNvSpPr txBox="1"/>
+          <p:nvPr/>
+        </p:nvSpPr>
+        <p:spPr>
+          <a:xfrm>
+            <a:off x="795528" y="5943600"/>
+            <a:ext cx="1737360" cy="384048"/>
+          </a:xfrm>
+          <a:prstGeom prst="rect">
+            <a:avLst/>
+          </a:prstGeom>
+          <a:noFill/>
+        </p:spPr>
+        <p:txBody>
+          <a:bodyPr wrap="square" anchor="ctr" lIns="0" rIns="0" tIns="0" bIns="0">
+            <a:spAutoFit/>
+          </a:bodyPr>
+          <a:lstStyle/>
+          <a:p>
+            <a:pPr algn="l"/>
+            <a:r>
+              <a:rPr sz="1350" b="1">
+                <a:solidFill>
+                  <a:srgbClr val="2E7D4F"/>
+                </a:solidFill>
+                <a:latin typeface="微软雅黑"/>
+                <a:ea typeface="微软雅黑"/>
+              </a:rPr>
+              <a:t>terminal</a:t>
+            </a:r>
+          </a:p>
+        </p:txBody>
+      </p:sp>
+      <p:sp>
+        <p:nvSpPr>
+          <p:cNvPr id="12" name="TextBox 11"/>
+          <p:cNvSpPr txBox="1"/>
+          <p:nvPr/>
+        </p:nvSpPr>
+        <p:spPr>
+          <a:xfrm>
+            <a:off x="2487168" y="5943600"/>
+            <a:ext cx="1645920" cy="384048"/>
+          </a:xfrm>
+          <a:prstGeom prst="rect">
+            <a:avLst/>
+          </a:prstGeom>
+          <a:noFill/>
+        </p:spPr>
+        <p:txBody>
+          <a:bodyPr wrap="square" anchor="ctr" lIns="0" rIns="0" tIns="0" bIns="0">
+            <a:spAutoFit/>
+          </a:bodyPr>
+          <a:lstStyle/>
+          <a:p>
+            <a:pPr algn="l"/>
+            <a:r>
+              <a:rPr sz="1100" b="0">
+                <a:solidFill>
+                  <a:srgbClr val="2B2B2B"/>
+                </a:solidFill>
+                <a:latin typeface="微软雅黑"/>
+                <a:ea typeface="微软雅黑"/>
+              </a:rPr>
+              <a:t>终局:防守方胜或和棋</a:t>
+            </a:r>
+          </a:p>
+        </p:txBody>
+      </p:sp>
+      <p:sp>
+        <p:nvSpPr>
+          <p:cNvPr id="13" name="Rounded Rectangle 12"/>
           <p:cNvSpPr/>
           <p:nvPr/>
         </p:nvSpPr>
         <p:spPr>
           <a:xfrm>
-            <a:off x="566928" y="4526280"/>
-            <a:ext cx="11055096" cy="365760"/>
+            <a:off x="4343400" y="5897880"/>
+            <a:ext cx="3593592" cy="457200"/>
           </a:xfrm>
           <a:prstGeom prst="roundRect">
             <a:avLst>
-              <a:gd name="adj" fmla="val 10000"/>
+              <a:gd name="adj" fmla="val 12000"/>
             </a:avLst>
           </a:prstGeom>
           <a:solidFill>
-            <a:srgbClr val="2C3E63"/>
+            <a:srgbClr val="F1F3F7"/>
           </a:solidFill>
           <a:ln>
             <a:noFill/>
@@ -10638,33 +10744,23 @@
           </a:fontRef>
         </p:style>
         <p:txBody>
-          <a:bodyPr rtlCol="0" anchor="ctr" wrap="square" lIns="73152" rIns="73152" tIns="36576" bIns="36576"/>
-          <a:lstStyle/>
-          <a:p>
-            <a:pPr algn="ctr"/>
-            <a:r>
-              <a:rPr sz="1200" b="1">
-                <a:solidFill>
-                  <a:srgbClr val="FFFFFF"/>
-                </a:solidFill>
-                <a:latin typeface="微软雅黑"/>
-                <a:ea typeface="微软雅黑"/>
-              </a:rPr>
-              <a:t>checkDefenseNode — 攻击方全应手覆盖是硬约束</a:t>
-            </a:r>
-          </a:p>
-        </p:txBody>
-      </p:sp>
-      <p:sp>
-        <p:nvSpPr>
-          <p:cNvPr id="12" name="TextBox 11"/>
+          <a:bodyPr rtlCol="0" anchor="ctr"/>
+          <a:lstStyle/>
+          <a:p>
+            <a:pPr algn="ctr"/>
+          </a:p>
+        </p:txBody>
+      </p:sp>
+      <p:sp>
+        <p:nvSpPr>
+          <p:cNvPr id="14" name="TextBox 13"/>
           <p:cNvSpPr txBox="1"/>
           <p:nvPr/>
         </p:nvSpPr>
         <p:spPr>
           <a:xfrm>
-            <a:off x="795528" y="4983480"/>
-            <a:ext cx="10597896" cy="1216152"/>
+            <a:off x="4572000" y="5943600"/>
+            <a:ext cx="1737360" cy="384048"/>
           </a:xfrm>
           <a:prstGeom prst="rect">
             <a:avLst/>
@@ -10672,111 +10768,182 @@
           <a:noFill/>
         </p:spPr>
         <p:txBody>
-          <a:bodyPr wrap="none">
+          <a:bodyPr wrap="square" anchor="ctr" lIns="0" rIns="0" tIns="0" bIns="0">
             <a:spAutoFit/>
           </a:bodyPr>
           <a:lstStyle/>
           <a:p>
-            <a:r>
-              <a:rPr sz="1150" b="1">
-                <a:solidFill>
-                  <a:srgbClr val="7DC4FF"/>
-                </a:solidFill>
-                <a:latin typeface="Consolas"/>
-                <a:ea typeface="微软雅黑"/>
-              </a:rPr>
-              <a:t>def checkDefenseNode (defender : Player) (size : Nat) : DefenseCertificateNode → Bool</a:t>
-            </a:r>
-          </a:p>
-          <a:p>
-            <a:r>
-              <a:rPr sz="1150" b="0">
-                <a:solidFill>
-                  <a:srgbClr val="E8ECF4"/>
-                </a:solidFill>
-                <a:latin typeface="Consolas"/>
-                <a:ea typeface="微软雅黑"/>
-              </a:rPr>
-              <a:t>  | .terminal s out =&gt;</a:t>
-            </a:r>
-          </a:p>
-          <a:p>
-            <a:r>
-              <a:rPr sz="1150" b="0">
-                <a:solidFill>
-                  <a:srgbClr val="E8ECF4"/>
-                </a:solidFill>
-                <a:latin typeface="Consolas"/>
-                <a:ea typeface="微软雅黑"/>
-              </a:rPr>
-              <a:t>      decide (terminal s = some out) &amp;&amp;</a:t>
-            </a:r>
-          </a:p>
-          <a:p>
-            <a:r>
-              <a:rPr sz="1150" b="0">
-                <a:solidFill>
-                  <a:srgbClr val="E8ECF4"/>
-                </a:solidFill>
-                <a:latin typeface="Consolas"/>
-                <a:ea typeface="微软雅黑"/>
-              </a:rPr>
-              <a:t>        (decide (out = winner defender) || decide (out = .draw))</a:t>
-            </a:r>
-          </a:p>
-          <a:p>
-            <a:r>
-              <a:rPr sz="1150" b="0">
-                <a:solidFill>
-                  <a:srgbClr val="E8ECF4"/>
-                </a:solidFill>
-                <a:latin typeface="Consolas"/>
-                <a:ea typeface="微软雅黑"/>
-              </a:rPr>
-              <a:t>  | .attackerMoves s children =&gt;</a:t>
-            </a:r>
-          </a:p>
-          <a:p>
-            <a:r>
-              <a:rPr sz="1150" b="0">
-                <a:solidFill>
-                  <a:srgbClr val="E8ECF4"/>
-                </a:solidFill>
-                <a:latin typeface="Consolas"/>
-                <a:ea typeface="微软雅黑"/>
-              </a:rPr>
-              <a:t>      decide (terminal s = none) &amp;&amp; decide (s.turn = Player.other defender) &amp;&amp;</a:t>
-            </a:r>
-          </a:p>
-          <a:p>
-            <a:r>
-              <a:rPr sz="1150" b="0">
-                <a:solidFill>
-                  <a:srgbClr val="E8ECF4"/>
-                </a:solidFill>
-                <a:latin typeface="Consolas"/>
-                <a:ea typeface="微软雅黑"/>
-              </a:rPr>
-              <a:t>        allRefsValid size children &amp;&amp; allMovesLegal s children &amp;&amp;</a:t>
-            </a:r>
-          </a:p>
-          <a:p>
-            <a:r>
-              <a:rPr sz="1150" b="0">
-                <a:solidFill>
-                  <a:srgbClr val="E8ECF4"/>
-                </a:solidFill>
-                <a:latin typeface="Consolas"/>
-                <a:ea typeface="微软雅黑"/>
-              </a:rPr>
-              <a:t>        allLegalMovesCovered s children &amp;&amp; movesDistinct children</a:t>
-            </a:r>
-          </a:p>
-        </p:txBody>
-      </p:sp>
-      <p:sp>
-        <p:nvSpPr>
-          <p:cNvPr id="13" name="TextBox 12"/>
+            <a:pPr algn="l"/>
+            <a:r>
+              <a:rPr sz="1350" b="1">
+                <a:solidFill>
+                  <a:srgbClr val="3B5998"/>
+                </a:solidFill>
+                <a:latin typeface="微软雅黑"/>
+                <a:ea typeface="微软雅黑"/>
+              </a:rPr>
+              <a:t>defenderMove</a:t>
+            </a:r>
+          </a:p>
+        </p:txBody>
+      </p:sp>
+      <p:sp>
+        <p:nvSpPr>
+          <p:cNvPr id="15" name="TextBox 14"/>
+          <p:cNvSpPr txBox="1"/>
+          <p:nvPr/>
+        </p:nvSpPr>
+        <p:spPr>
+          <a:xfrm>
+            <a:off x="6263640" y="5943600"/>
+            <a:ext cx="1645920" cy="384048"/>
+          </a:xfrm>
+          <a:prstGeom prst="rect">
+            <a:avLst/>
+          </a:prstGeom>
+          <a:noFill/>
+        </p:spPr>
+        <p:txBody>
+          <a:bodyPr wrap="square" anchor="ctr" lIns="0" rIns="0" tIns="0" bIns="0">
+            <a:spAutoFit/>
+          </a:bodyPr>
+          <a:lstStyle/>
+          <a:p>
+            <a:pPr algn="l"/>
+            <a:r>
+              <a:rPr sz="1100" b="0">
+                <a:solidFill>
+                  <a:srgbClr val="2B2B2B"/>
+                </a:solidFill>
+                <a:latin typeface="微软雅黑"/>
+                <a:ea typeface="微软雅黑"/>
+              </a:rPr>
+              <a:t>防守方选一步 → child</a:t>
+            </a:r>
+          </a:p>
+        </p:txBody>
+      </p:sp>
+      <p:sp>
+        <p:nvSpPr>
+          <p:cNvPr id="16" name="Rounded Rectangle 15"/>
+          <p:cNvSpPr/>
+          <p:nvPr/>
+        </p:nvSpPr>
+        <p:spPr>
+          <a:xfrm>
+            <a:off x="8119871" y="5897880"/>
+            <a:ext cx="3593592" cy="457200"/>
+          </a:xfrm>
+          <a:prstGeom prst="roundRect">
+            <a:avLst>
+              <a:gd name="adj" fmla="val 12000"/>
+            </a:avLst>
+          </a:prstGeom>
+          <a:solidFill>
+            <a:srgbClr val="F1F3F7"/>
+          </a:solidFill>
+          <a:ln>
+            <a:noFill/>
+          </a:ln>
+          <a:effectLst/>
+        </p:spPr>
+        <p:style>
+          <a:lnRef idx="1">
+            <a:schemeClr val="accent1"/>
+          </a:lnRef>
+          <a:fillRef idx="3">
+            <a:schemeClr val="accent1"/>
+          </a:fillRef>
+          <a:effectRef idx="2">
+            <a:schemeClr val="accent1"/>
+          </a:effectRef>
+          <a:fontRef idx="minor">
+            <a:schemeClr val="lt1"/>
+          </a:fontRef>
+        </p:style>
+        <p:txBody>
+          <a:bodyPr rtlCol="0" anchor="ctr"/>
+          <a:lstStyle/>
+          <a:p>
+            <a:pPr algn="ctr"/>
+          </a:p>
+        </p:txBody>
+      </p:sp>
+      <p:sp>
+        <p:nvSpPr>
+          <p:cNvPr id="17" name="TextBox 16"/>
+          <p:cNvSpPr txBox="1"/>
+          <p:nvPr/>
+        </p:nvSpPr>
+        <p:spPr>
+          <a:xfrm>
+            <a:off x="8348471" y="5943600"/>
+            <a:ext cx="1737360" cy="384048"/>
+          </a:xfrm>
+          <a:prstGeom prst="rect">
+            <a:avLst/>
+          </a:prstGeom>
+          <a:noFill/>
+        </p:spPr>
+        <p:txBody>
+          <a:bodyPr wrap="square" anchor="ctr" lIns="0" rIns="0" tIns="0" bIns="0">
+            <a:spAutoFit/>
+          </a:bodyPr>
+          <a:lstStyle/>
+          <a:p>
+            <a:pPr algn="l"/>
+            <a:r>
+              <a:rPr sz="1350" b="1">
+                <a:solidFill>
+                  <a:srgbClr val="D97B29"/>
+                </a:solidFill>
+                <a:latin typeface="微软雅黑"/>
+                <a:ea typeface="微软雅黑"/>
+              </a:rPr>
+              <a:t>attackerMoves</a:t>
+            </a:r>
+          </a:p>
+        </p:txBody>
+      </p:sp>
+      <p:sp>
+        <p:nvSpPr>
+          <p:cNvPr id="18" name="TextBox 17"/>
+          <p:cNvSpPr txBox="1"/>
+          <p:nvPr/>
+        </p:nvSpPr>
+        <p:spPr>
+          <a:xfrm>
+            <a:off x="10040111" y="5943600"/>
+            <a:ext cx="1645920" cy="384048"/>
+          </a:xfrm>
+          <a:prstGeom prst="rect">
+            <a:avLst/>
+          </a:prstGeom>
+          <a:noFill/>
+        </p:spPr>
+        <p:txBody>
+          <a:bodyPr wrap="square" anchor="ctr" lIns="0" rIns="0" tIns="0" bIns="0">
+            <a:spAutoFit/>
+          </a:bodyPr>
+          <a:lstStyle/>
+          <a:p>
+            <a:pPr algn="l"/>
+            <a:r>
+              <a:rPr sz="1100" b="0">
+                <a:solidFill>
+                  <a:srgbClr val="2B2B2B"/>
+                </a:solidFill>
+                <a:latin typeface="微软雅黑"/>
+                <a:ea typeface="微软雅黑"/>
+              </a:rPr>
+              <a:t>攻击方全应手 → children</a:t>
+            </a:r>
+          </a:p>
+        </p:txBody>
+      </p:sp>
+      <p:sp>
+        <p:nvSpPr>
+          <p:cNvPr id="19" name="TextBox 18"/>
           <p:cNvSpPr txBox="1"/>
           <p:nvPr/>
         </p:nvSpPr>
@@ -10812,7 +10979,7 @@
       </p:sp>
       <p:sp>
         <p:nvSpPr>
-          <p:cNvPr id="14" name="TextBox 13"/>
+          <p:cNvPr id="20" name="TextBox 19"/>
           <p:cNvSpPr txBox="1"/>
           <p:nvPr/>
         </p:nvSpPr>
@@ -13550,7 +13717,7 @@
                 <a:latin typeface="微软雅黑"/>
                 <a:ea typeface="微软雅黑"/>
               </a:rPr>
-              <a:t>证书只是候选：Lean 检查器逐节点重算通过后，才能组合出 StandardDraw 定理。</a:t>
+              <a:t>每个局面都有白防黑、黑防白两张防守证书，分别给出双方的阻止获胜结论。</a:t>
             </a:r>
           </a:p>
         </p:txBody>
@@ -14090,7 +14257,7 @@
                 <a:latin typeface="微软雅黑"/>
                 <a:ea typeface="微软雅黑"/>
               </a:rPr>
-              <a:t>代码对照 ③：从证书到 StandardDraw 定理</a:t>
+              <a:t>代码对照 ③：两张证书 → StandardDraw 定理</a:t>
             </a:r>
           </a:p>
         </p:txBody>
@@ -14162,7 +14329,7 @@
                 <a:latin typeface="微软雅黑"/>
                 <a:ea typeface="微软雅黑"/>
               </a:rPr>
-              <a:t>C++ 生成的 Lean 文件：检查器验证两张证书，soundness 定理组合出和棋。</a:t>
+              <a:t>C++ 生成的 Lean 文件：白防黑 + 黑防白两张防守证书，用 soundness 定理组合出和棋结论。</a:t>
             </a:r>
           </a:p>
         </p:txBody>
@@ -14176,7 +14343,7 @@
         <p:spPr>
           <a:xfrm>
             <a:off x="566928" y="1554480"/>
-            <a:ext cx="11055096" cy="2377440"/>
+            <a:ext cx="11055096" cy="3017520"/>
           </a:xfrm>
           <a:prstGeom prst="roundRect">
             <a:avLst>
@@ -14266,7 +14433,7 @@
                 <a:latin typeface="微软雅黑"/>
                 <a:ea typeface="微软雅黑"/>
               </a:rPr>
-              <a:t>两张证书的检查（Gomoku/Generated/Draw7x7.lean）</a:t>
+              <a:t>两张防守证书 → 和棋定理（Gomoku/Generated/Draw7x7.lean）</a:t>
             </a:r>
           </a:p>
         </p:txBody>
@@ -14280,7 +14447,7 @@
         <p:spPr>
           <a:xfrm>
             <a:off x="795528" y="2011680"/>
-            <a:ext cx="10597896" cy="1810511"/>
+            <a:ext cx="10597896" cy="2450591"/>
           </a:xfrm>
           <a:prstGeom prst="rect">
             <a:avLst/>
@@ -14294,110 +14461,122 @@
           <a:lstStyle/>
           <a:p>
             <a:r>
-              <a:rPr sz="1200" b="1">
+              <a:rPr sz="1300" b="1">
                 <a:solidFill>
                   <a:srgbClr val="7DC4FF"/>
                 </a:solidFill>
                 <a:latin typeface="Consolas"/>
                 <a:ea typeface="微软雅黑"/>
               </a:rPr>
-              <a:t>theorem draw7x7WhiteChecked :</a:t>
-            </a:r>
-          </a:p>
-          <a:p>
-            <a:r>
-              <a:rPr sz="1200" b="0">
+              <a:t>theorem draw7x7WhitePrevents : WhiteCanPreventBlackWin draw7x7RootPosition</a:t>
+            </a:r>
+          </a:p>
+          <a:p>
+            <a:r>
+              <a:rPr sz="1300" b="0" i="1">
+                <a:solidFill>
+                  <a:srgbClr val="8A99B4"/>
+                </a:solidFill>
+                <a:latin typeface="Consolas"/>
+                <a:ea typeface="微软雅黑"/>
+              </a:rPr>
+              <a:t>  := white_defense_certificate_sound ...   -- 白防黑证书</a:t>
+            </a:r>
+          </a:p>
+          <a:p>
+            <a:r>
+              <a:rPr sz="1300" b="0">
                 <a:solidFill>
                   <a:srgbClr val="E8ECF4"/>
                 </a:solidFill>
                 <a:latin typeface="Consolas"/>
                 <a:ea typeface="微软雅黑"/>
               </a:rPr>
-              <a:t>    checkDefenseCertificateAt draw7x7RootPosition</a:t>
-            </a:r>
-          </a:p>
-          <a:p>
-            <a:r>
-              <a:rPr sz="1200" b="0">
+              <a:t/>
+            </a:r>
+          </a:p>
+          <a:p>
+            <a:r>
+              <a:rPr sz="1300" b="1">
+                <a:solidFill>
+                  <a:srgbClr val="7DC4FF"/>
+                </a:solidFill>
+                <a:latin typeface="Consolas"/>
+                <a:ea typeface="微软雅黑"/>
+              </a:rPr>
+              <a:t>theorem draw7x7BlackPrevents : BlackCanPreventWhiteWin draw7x7RootPosition</a:t>
+            </a:r>
+          </a:p>
+          <a:p>
+            <a:r>
+              <a:rPr sz="1300" b="0" i="1">
+                <a:solidFill>
+                  <a:srgbClr val="8A99B4"/>
+                </a:solidFill>
+                <a:latin typeface="Consolas"/>
+                <a:ea typeface="微软雅黑"/>
+              </a:rPr>
+              <a:t>  := black_defense_certificate_sound ...   -- 黑防白证书</a:t>
+            </a:r>
+          </a:p>
+          <a:p>
+            <a:r>
+              <a:rPr sz="1300" b="0">
                 <a:solidFill>
                   <a:srgbClr val="E8ECF4"/>
                 </a:solidFill>
                 <a:latin typeface="Consolas"/>
                 <a:ea typeface="微软雅黑"/>
               </a:rPr>
-              <a:t>        draw7x7WhiteDefenseCertificate = true := by</a:t>
-            </a:r>
-          </a:p>
-          <a:p>
-            <a:r>
-              <a:rPr sz="1200" b="0" i="1">
-                <a:solidFill>
-                  <a:srgbClr val="8A99B4"/>
+              <a:t/>
+            </a:r>
+          </a:p>
+          <a:p>
+            <a:r>
+              <a:rPr sz="1300" b="1">
+                <a:solidFill>
+                  <a:srgbClr val="7DC4FF"/>
                 </a:solidFill>
                 <a:latin typeface="Consolas"/>
                 <a:ea typeface="微软雅黑"/>
               </a:rPr>
-              <a:t>  native_decide   -- 机器重算：白防黑证书逐节点通过</a:t>
-            </a:r>
-          </a:p>
-          <a:p>
-            <a:r>
-              <a:rPr sz="1200" b="0">
+              <a:t>theorem draw7x7StandardDraw : StandardDraw draw7x7RootPosition :=</a:t>
+            </a:r>
+          </a:p>
+          <a:p>
+            <a:r>
+              <a:rPr sz="1300" b="0">
                 <a:solidFill>
                   <a:srgbClr val="E8ECF4"/>
                 </a:solidFill>
                 <a:latin typeface="Consolas"/>
                 <a:ea typeface="微软雅黑"/>
               </a:rPr>
-              <a:t/>
-            </a:r>
-          </a:p>
-          <a:p>
-            <a:r>
-              <a:rPr sz="1200" b="1">
-                <a:solidFill>
-                  <a:srgbClr val="7DC4FF"/>
+              <a:t>  standardDraw_of_mutualDefense</a:t>
+            </a:r>
+          </a:p>
+          <a:p>
+            <a:r>
+              <a:rPr sz="1300" b="0">
+                <a:solidFill>
+                  <a:srgbClr val="E8ECF4"/>
                 </a:solidFill>
                 <a:latin typeface="Consolas"/>
                 <a:ea typeface="微软雅黑"/>
               </a:rPr>
-              <a:t>theorem draw7x7BlackChecked :</a:t>
-            </a:r>
-          </a:p>
-          <a:p>
-            <a:r>
-              <a:rPr sz="1200" b="0">
+              <a:t>    draw7x7WhitePrevents</a:t>
+            </a:r>
+          </a:p>
+          <a:p>
+            <a:r>
+              <a:rPr sz="1300" b="0">
                 <a:solidFill>
                   <a:srgbClr val="E8ECF4"/>
                 </a:solidFill>
                 <a:latin typeface="Consolas"/>
                 <a:ea typeface="微软雅黑"/>
               </a:rPr>
-              <a:t>    checkDefenseCertificateAt draw7x7RootPosition</a:t>
-            </a:r>
-          </a:p>
-          <a:p>
-            <a:r>
-              <a:rPr sz="1200" b="0">
-                <a:solidFill>
-                  <a:srgbClr val="E8ECF4"/>
-                </a:solidFill>
-                <a:latin typeface="Consolas"/>
-                <a:ea typeface="微软雅黑"/>
-              </a:rPr>
-              <a:t>        draw7x7BlackDefenseCertificate = true := by</a:t>
-            </a:r>
-          </a:p>
-          <a:p>
-            <a:r>
-              <a:rPr sz="1200" b="0" i="1">
-                <a:solidFill>
-                  <a:srgbClr val="8A99B4"/>
-                </a:solidFill>
-                <a:latin typeface="Consolas"/>
-                <a:ea typeface="微软雅黑"/>
-              </a:rPr>
-              <a:t>  native_decide   -- 机器重算：黑防白证书逐节点通过</a:t>
+              <a:t>    draw7x7BlackPrevents</a:t>
             </a:r>
           </a:p>
         </p:txBody>
@@ -14410,21 +14589,19 @@
         </p:nvSpPr>
         <p:spPr>
           <a:xfrm>
-            <a:off x="566928" y="4069080"/>
-            <a:ext cx="11055096" cy="2148840"/>
+            <a:off x="566928" y="5029200"/>
+            <a:ext cx="3593592" cy="914400"/>
           </a:xfrm>
           <a:prstGeom prst="roundRect">
             <a:avLst>
-              <a:gd name="adj" fmla="val 4000"/>
+              <a:gd name="adj" fmla="val 10000"/>
             </a:avLst>
           </a:prstGeom>
           <a:solidFill>
-            <a:srgbClr val="141A2B"/>
+            <a:srgbClr val="F1F3F7"/>
           </a:solidFill>
-          <a:ln w="12700">
-            <a:solidFill>
-              <a:srgbClr val="3B5998"/>
-            </a:solidFill>
+          <a:ln>
+            <a:noFill/>
           </a:ln>
           <a:effectLst/>
         </p:spPr>
@@ -14452,14 +14629,86 @@
       </p:sp>
       <p:sp>
         <p:nvSpPr>
-          <p:cNvPr id="11" name="Rounded Rectangle 10"/>
+          <p:cNvPr id="11" name="TextBox 10"/>
+          <p:cNvSpPr txBox="1"/>
+          <p:nvPr/>
+        </p:nvSpPr>
+        <p:spPr>
+          <a:xfrm>
+            <a:off x="795528" y="5120640"/>
+            <a:ext cx="3200400" cy="365760"/>
+          </a:xfrm>
+          <a:prstGeom prst="rect">
+            <a:avLst/>
+          </a:prstGeom>
+          <a:noFill/>
+        </p:spPr>
+        <p:txBody>
+          <a:bodyPr wrap="square" anchor="t" lIns="0" rIns="0" tIns="0" bIns="0">
+            <a:spAutoFit/>
+          </a:bodyPr>
+          <a:lstStyle/>
+          <a:p>
+            <a:pPr algn="l"/>
+            <a:r>
+              <a:rPr sz="1150" b="1">
+                <a:solidFill>
+                  <a:srgbClr val="2E7D4F"/>
+                </a:solidFill>
+                <a:latin typeface="微软雅黑"/>
+                <a:ea typeface="微软雅黑"/>
+              </a:rPr>
+              <a:t>white_defense_certificate_sound</a:t>
+            </a:r>
+          </a:p>
+        </p:txBody>
+      </p:sp>
+      <p:sp>
+        <p:nvSpPr>
+          <p:cNvPr id="12" name="TextBox 11"/>
+          <p:cNvSpPr txBox="1"/>
+          <p:nvPr/>
+        </p:nvSpPr>
+        <p:spPr>
+          <a:xfrm>
+            <a:off x="795528" y="5486400"/>
+            <a:ext cx="3200400" cy="365760"/>
+          </a:xfrm>
+          <a:prstGeom prst="rect">
+            <a:avLst/>
+          </a:prstGeom>
+          <a:noFill/>
+        </p:spPr>
+        <p:txBody>
+          <a:bodyPr wrap="square" anchor="t" lIns="0" rIns="0" tIns="0" bIns="0">
+            <a:spAutoFit/>
+          </a:bodyPr>
+          <a:lstStyle/>
+          <a:p>
+            <a:pPr algn="l"/>
+            <a:r>
+              <a:rPr sz="1100" b="0">
+                <a:solidFill>
+                  <a:srgbClr val="2B2B2B"/>
+                </a:solidFill>
+                <a:latin typeface="微软雅黑"/>
+                <a:ea typeface="微软雅黑"/>
+              </a:rPr>
+              <a:t>白防黑 → WhiteCanPreventBlackWin</a:t>
+            </a:r>
+          </a:p>
+        </p:txBody>
+      </p:sp>
+      <p:sp>
+        <p:nvSpPr>
+          <p:cNvPr id="13" name="Rounded Rectangle 12"/>
           <p:cNvSpPr/>
           <p:nvPr/>
         </p:nvSpPr>
         <p:spPr>
           <a:xfrm>
-            <a:off x="566928" y="4069080"/>
-            <a:ext cx="11055096" cy="365760"/>
+            <a:off x="4343400" y="5029200"/>
+            <a:ext cx="3593592" cy="914400"/>
           </a:xfrm>
           <a:prstGeom prst="roundRect">
             <a:avLst>
@@ -14467,7 +14716,7 @@
             </a:avLst>
           </a:prstGeom>
           <a:solidFill>
-            <a:srgbClr val="2C3E63"/>
+            <a:srgbClr val="F1F3F7"/>
           </a:solidFill>
           <a:ln>
             <a:noFill/>
@@ -14489,33 +14738,23 @@
           </a:fontRef>
         </p:style>
         <p:txBody>
-          <a:bodyPr rtlCol="0" anchor="ctr" wrap="square" lIns="73152" rIns="73152" tIns="36576" bIns="36576"/>
-          <a:lstStyle/>
-          <a:p>
-            <a:pPr algn="ctr"/>
-            <a:r>
-              <a:rPr sz="1200" b="1">
-                <a:solidFill>
-                  <a:srgbClr val="FFFFFF"/>
-                </a:solidFill>
-                <a:latin typeface="微软雅黑"/>
-                <a:ea typeface="微软雅黑"/>
-              </a:rPr>
-              <a:t>组合定理（依赖 Defense.lean 的 soundness）</a:t>
-            </a:r>
-          </a:p>
-        </p:txBody>
-      </p:sp>
-      <p:sp>
-        <p:nvSpPr>
-          <p:cNvPr id="12" name="TextBox 11"/>
+          <a:bodyPr rtlCol="0" anchor="ctr"/>
+          <a:lstStyle/>
+          <a:p>
+            <a:pPr algn="ctr"/>
+          </a:p>
+        </p:txBody>
+      </p:sp>
+      <p:sp>
+        <p:nvSpPr>
+          <p:cNvPr id="14" name="TextBox 13"/>
           <p:cNvSpPr txBox="1"/>
           <p:nvPr/>
         </p:nvSpPr>
         <p:spPr>
           <a:xfrm>
-            <a:off x="795528" y="4526280"/>
-            <a:ext cx="10597896" cy="1581912"/>
+            <a:off x="4572000" y="5120640"/>
+            <a:ext cx="3200400" cy="365760"/>
           </a:xfrm>
           <a:prstGeom prst="rect">
             <a:avLst/>
@@ -14523,102 +14762,79 @@
           <a:noFill/>
         </p:spPr>
         <p:txBody>
-          <a:bodyPr wrap="none">
+          <a:bodyPr wrap="square" anchor="t" lIns="0" rIns="0" tIns="0" bIns="0">
             <a:spAutoFit/>
           </a:bodyPr>
           <a:lstStyle/>
           <a:p>
-            <a:r>
-              <a:rPr sz="1200" b="1">
-                <a:solidFill>
-                  <a:srgbClr val="7DC4FF"/>
-                </a:solidFill>
-                <a:latin typeface="Consolas"/>
-                <a:ea typeface="微软雅黑"/>
-              </a:rPr>
-              <a:t>theorem draw7x7StandardDraw : StandardDraw draw7x7RootPosition :=</a:t>
-            </a:r>
-          </a:p>
-          <a:p>
-            <a:r>
-              <a:rPr sz="1200" b="0">
-                <a:solidFill>
-                  <a:srgbClr val="E8ECF4"/>
-                </a:solidFill>
-                <a:latin typeface="Consolas"/>
-                <a:ea typeface="微软雅黑"/>
-              </a:rPr>
-              <a:t>  standardDraw_of_mutualDefense</a:t>
-            </a:r>
-          </a:p>
-          <a:p>
-            <a:r>
-              <a:rPr sz="1200" b="0" i="1">
-                <a:solidFill>
-                  <a:srgbClr val="8A99B4"/>
-                </a:solidFill>
-                <a:latin typeface="Consolas"/>
-                <a:ea typeface="微软雅黑"/>
-              </a:rPr>
-              <a:t>    draw7x7WhitePrevents   -- WhiteCanPreventBlackWin draw7x7RootPosition</a:t>
-            </a:r>
-          </a:p>
-          <a:p>
-            <a:r>
-              <a:rPr sz="1200" b="0" i="1">
-                <a:solidFill>
-                  <a:srgbClr val="8A99B4"/>
-                </a:solidFill>
-                <a:latin typeface="Consolas"/>
-                <a:ea typeface="微软雅黑"/>
-              </a:rPr>
-              <a:t>    draw7x7BlackPrevents   -- BlackCanPreventWhiteWin draw7x7RootPosition</a:t>
-            </a:r>
-          </a:p>
-          <a:p>
-            <a:r>
-              <a:rPr sz="1200" b="0">
-                <a:solidFill>
-                  <a:srgbClr val="E8ECF4"/>
-                </a:solidFill>
-                <a:latin typeface="Consolas"/>
-                <a:ea typeface="微软雅黑"/>
-              </a:rPr>
-              <a:t/>
-            </a:r>
-          </a:p>
-          <a:p>
-            <a:r>
-              <a:rPr sz="1200" b="0" i="1">
-                <a:solidFill>
-                  <a:srgbClr val="8A99B4"/>
-                </a:solidFill>
-                <a:latin typeface="Consolas"/>
-                <a:ea typeface="微软雅黑"/>
-              </a:rPr>
-              <a:t>-- 信任边界：搜索器只提供证书数据；定理由 Lean 内核 + soundness 证明保证</a:t>
-            </a:r>
-          </a:p>
-        </p:txBody>
-      </p:sp>
-      <p:sp>
-        <p:nvSpPr>
-          <p:cNvPr id="13" name="Rounded Rectangle 12"/>
+            <a:pPr algn="l"/>
+            <a:r>
+              <a:rPr sz="1150" b="1">
+                <a:solidFill>
+                  <a:srgbClr val="3B5998"/>
+                </a:solidFill>
+                <a:latin typeface="微软雅黑"/>
+                <a:ea typeface="微软雅黑"/>
+              </a:rPr>
+              <a:t>black_defense_certificate_sound</a:t>
+            </a:r>
+          </a:p>
+        </p:txBody>
+      </p:sp>
+      <p:sp>
+        <p:nvSpPr>
+          <p:cNvPr id="15" name="TextBox 14"/>
+          <p:cNvSpPr txBox="1"/>
+          <p:nvPr/>
+        </p:nvSpPr>
+        <p:spPr>
+          <a:xfrm>
+            <a:off x="4572000" y="5486400"/>
+            <a:ext cx="3200400" cy="365760"/>
+          </a:xfrm>
+          <a:prstGeom prst="rect">
+            <a:avLst/>
+          </a:prstGeom>
+          <a:noFill/>
+        </p:spPr>
+        <p:txBody>
+          <a:bodyPr wrap="square" anchor="t" lIns="0" rIns="0" tIns="0" bIns="0">
+            <a:spAutoFit/>
+          </a:bodyPr>
+          <a:lstStyle/>
+          <a:p>
+            <a:pPr algn="l"/>
+            <a:r>
+              <a:rPr sz="1100" b="0">
+                <a:solidFill>
+                  <a:srgbClr val="2B2B2B"/>
+                </a:solidFill>
+                <a:latin typeface="微软雅黑"/>
+                <a:ea typeface="微软雅黑"/>
+              </a:rPr>
+              <a:t>黑防白 → BlackCanPreventWhiteWin</a:t>
+            </a:r>
+          </a:p>
+        </p:txBody>
+      </p:sp>
+      <p:sp>
+        <p:nvSpPr>
+          <p:cNvPr id="16" name="Rounded Rectangle 15"/>
           <p:cNvSpPr/>
           <p:nvPr/>
         </p:nvSpPr>
         <p:spPr>
           <a:xfrm>
-            <a:off x="566928" y="6355080"/>
-            <a:ext cx="11055096" cy="384048"/>
+            <a:off x="8119871" y="5029200"/>
+            <a:ext cx="3593592" cy="914400"/>
           </a:xfrm>
           <a:prstGeom prst="roundRect">
             <a:avLst>
-              <a:gd name="adj" fmla="val 18000"/>
+              <a:gd name="adj" fmla="val 10000"/>
             </a:avLst>
           </a:prstGeom>
           <a:solidFill>
-            <a:srgbClr val="FBEFDA"/>
+            <a:srgbClr val="F1F3F7"/>
           </a:solidFill>
           <a:ln>
             <a:noFill/>
@@ -14640,33 +14856,23 @@
           </a:fontRef>
         </p:style>
         <p:txBody>
-          <a:bodyPr rtlCol="0" anchor="ctr" wrap="square" lIns="73152" rIns="73152" tIns="36576" bIns="36576"/>
-          <a:lstStyle/>
-          <a:p>
-            <a:pPr algn="ctr"/>
-            <a:r>
-              <a:rPr sz="1250" b="1">
-                <a:solidFill>
-                  <a:srgbClr val="C98A2D"/>
-                </a:solidFill>
-                <a:latin typeface="微软雅黑"/>
-                <a:ea typeface="微软雅黑"/>
-              </a:rPr>
-              <a:t>检查器重算 + soundness 定理 = 不信任搜索器也能得到真定理。</a:t>
-            </a:r>
-          </a:p>
-        </p:txBody>
-      </p:sp>
-      <p:sp>
-        <p:nvSpPr>
-          <p:cNvPr id="14" name="TextBox 13"/>
+          <a:bodyPr rtlCol="0" anchor="ctr"/>
+          <a:lstStyle/>
+          <a:p>
+            <a:pPr algn="ctr"/>
+          </a:p>
+        </p:txBody>
+      </p:sp>
+      <p:sp>
+        <p:nvSpPr>
+          <p:cNvPr id="17" name="TextBox 16"/>
           <p:cNvSpPr txBox="1"/>
           <p:nvPr/>
         </p:nvSpPr>
         <p:spPr>
           <a:xfrm>
-            <a:off x="566928" y="6510528"/>
-            <a:ext cx="5486400" cy="274320"/>
+            <a:off x="8348471" y="5120640"/>
+            <a:ext cx="3200400" cy="365760"/>
           </a:xfrm>
           <a:prstGeom prst="rect">
             <a:avLst/>
@@ -14681,6 +14887,78 @@
           <a:p>
             <a:pPr algn="l"/>
             <a:r>
+              <a:rPr sz="1150" b="1">
+                <a:solidFill>
+                  <a:srgbClr val="D97B29"/>
+                </a:solidFill>
+                <a:latin typeface="微软雅黑"/>
+                <a:ea typeface="微软雅黑"/>
+              </a:rPr>
+              <a:t>standardDraw_of_mutualDefense</a:t>
+            </a:r>
+          </a:p>
+        </p:txBody>
+      </p:sp>
+      <p:sp>
+        <p:nvSpPr>
+          <p:cNvPr id="18" name="TextBox 17"/>
+          <p:cNvSpPr txBox="1"/>
+          <p:nvPr/>
+        </p:nvSpPr>
+        <p:spPr>
+          <a:xfrm>
+            <a:off x="8348471" y="5486400"/>
+            <a:ext cx="3200400" cy="365760"/>
+          </a:xfrm>
+          <a:prstGeom prst="rect">
+            <a:avLst/>
+          </a:prstGeom>
+          <a:noFill/>
+        </p:spPr>
+        <p:txBody>
+          <a:bodyPr wrap="square" anchor="t" lIns="0" rIns="0" tIns="0" bIns="0">
+            <a:spAutoFit/>
+          </a:bodyPr>
+          <a:lstStyle/>
+          <a:p>
+            <a:pPr algn="l"/>
+            <a:r>
+              <a:rPr sz="1100" b="0">
+                <a:solidFill>
+                  <a:srgbClr val="2B2B2B"/>
+                </a:solidFill>
+                <a:latin typeface="微软雅黑"/>
+                <a:ea typeface="微软雅黑"/>
+              </a:rPr>
+              <a:t>两者组合 → StandardDraw</a:t>
+            </a:r>
+          </a:p>
+        </p:txBody>
+      </p:sp>
+      <p:sp>
+        <p:nvSpPr>
+          <p:cNvPr id="19" name="TextBox 18"/>
+          <p:cNvSpPr txBox="1"/>
+          <p:nvPr/>
+        </p:nvSpPr>
+        <p:spPr>
+          <a:xfrm>
+            <a:off x="566928" y="6510528"/>
+            <a:ext cx="5486400" cy="274320"/>
+          </a:xfrm>
+          <a:prstGeom prst="rect">
+            <a:avLst/>
+          </a:prstGeom>
+          <a:noFill/>
+        </p:spPr>
+        <p:txBody>
+          <a:bodyPr wrap="square" anchor="t" lIns="0" rIns="0" tIns="0" bIns="0">
+            <a:spAutoFit/>
+          </a:bodyPr>
+          <a:lstStyle/>
+          <a:p>
+            <a:pPr algn="l"/>
+            <a:r>
               <a:rPr sz="900" b="0">
                 <a:solidFill>
                   <a:srgbClr val="6B7480"/>
@@ -14695,7 +14973,7 @@
       </p:sp>
       <p:sp>
         <p:nvSpPr>
-          <p:cNvPr id="15" name="TextBox 14"/>
+          <p:cNvPr id="20" name="TextBox 19"/>
           <p:cNvSpPr txBox="1"/>
           <p:nvPr/>
         </p:nvSpPr>

</xml_diff>